<commit_message>
Added to Lab A
</commit_message>
<xml_diff>
--- a/docs/chapters/images.pptx
+++ b/docs/chapters/images.pptx
@@ -5,7 +5,7 @@
     <p:sldMasterId id="2147483648" r:id="rId1"/>
   </p:sldMasterIdLst>
   <p:notesMasterIdLst>
-    <p:notesMasterId r:id="rId14"/>
+    <p:notesMasterId r:id="rId19"/>
   </p:notesMasterIdLst>
   <p:sldIdLst>
     <p:sldId id="256" r:id="rId2"/>
@@ -20,6 +20,11 @@
     <p:sldId id="265" r:id="rId11"/>
     <p:sldId id="266" r:id="rId12"/>
     <p:sldId id="267" r:id="rId13"/>
+    <p:sldId id="268" r:id="rId14"/>
+    <p:sldId id="269" r:id="rId15"/>
+    <p:sldId id="270" r:id="rId16"/>
+    <p:sldId id="271" r:id="rId17"/>
+    <p:sldId id="272" r:id="rId18"/>
   </p:sldIdLst>
   <p:sldSz cx="12192000" cy="6858000"/>
   <p:notesSz cx="6858000" cy="9144000"/>
@@ -129,7 +134,7 @@
 <file path=ppt/revisionInfo.xml><?xml version="1.0" encoding="utf-8"?>
 <p1510:revInfo xmlns:a="http://schemas.openxmlformats.org/drawingml/2006/main" xmlns:r="http://schemas.openxmlformats.org/officeDocument/2006/relationships" xmlns:p1510="http://schemas.microsoft.com/office/powerpoint/2015/10/main">
   <p1510:revLst>
-    <p1510:client id="{7D97CB1E-4F7A-4B5D-BAC2-AE8954581E6E}" v="30" dt="2025-06-24T05:58:59.349"/>
+    <p1510:client id="{7D97CB1E-4F7A-4B5D-BAC2-AE8954581E6E}" v="43" dt="2025-06-24T16:21:19.714"/>
   </p1510:revLst>
 </p1510:revInfo>
 </file>
@@ -431,7 +436,7 @@
   <pc:docChgLst>
     <pc:chgData name="Alex Casson" userId="53cffa54-f866-4b4c-8e51-0383f28edfe1" providerId="ADAL" clId="{7D97CB1E-4F7A-4B5D-BAC2-AE8954581E6E}"/>
     <pc:docChg chg="undo custSel addSld modSld">
-      <pc:chgData name="Alex Casson" userId="53cffa54-f866-4b4c-8e51-0383f28edfe1" providerId="ADAL" clId="{7D97CB1E-4F7A-4B5D-BAC2-AE8954581E6E}" dt="2025-06-24T05:59:32.140" v="275" actId="1076"/>
+      <pc:chgData name="Alex Casson" userId="53cffa54-f866-4b4c-8e51-0383f28edfe1" providerId="ADAL" clId="{7D97CB1E-4F7A-4B5D-BAC2-AE8954581E6E}" dt="2025-06-24T16:21:33.884" v="654" actId="14100"/>
       <pc:docMkLst>
         <pc:docMk/>
       </pc:docMkLst>
@@ -951,6 +956,265 @@
             <pc:docMk/>
             <pc:sldMk cId="2381781374" sldId="267"/>
             <ac:picMk id="5" creationId="{12D82434-D5E0-433C-9957-1DCEACA6DAE2}"/>
+          </ac:picMkLst>
+        </pc:picChg>
+      </pc:sldChg>
+      <pc:sldChg chg="addSp delSp new mod">
+        <pc:chgData name="Alex Casson" userId="53cffa54-f866-4b4c-8e51-0383f28edfe1" providerId="ADAL" clId="{7D97CB1E-4F7A-4B5D-BAC2-AE8954581E6E}" dt="2025-06-24T12:55:32.612" v="279" actId="22"/>
+        <pc:sldMkLst>
+          <pc:docMk/>
+          <pc:sldMk cId="3675270851" sldId="268"/>
+        </pc:sldMkLst>
+        <pc:spChg chg="del">
+          <ac:chgData name="Alex Casson" userId="53cffa54-f866-4b4c-8e51-0383f28edfe1" providerId="ADAL" clId="{7D97CB1E-4F7A-4B5D-BAC2-AE8954581E6E}" dt="2025-06-24T12:55:30.837" v="277" actId="478"/>
+          <ac:spMkLst>
+            <pc:docMk/>
+            <pc:sldMk cId="3675270851" sldId="268"/>
+            <ac:spMk id="2" creationId="{4B87F4CE-0846-293F-5FD1-F50DE23D7287}"/>
+          </ac:spMkLst>
+        </pc:spChg>
+        <pc:spChg chg="del">
+          <ac:chgData name="Alex Casson" userId="53cffa54-f866-4b4c-8e51-0383f28edfe1" providerId="ADAL" clId="{7D97CB1E-4F7A-4B5D-BAC2-AE8954581E6E}" dt="2025-06-24T12:55:31.597" v="278" actId="478"/>
+          <ac:spMkLst>
+            <pc:docMk/>
+            <pc:sldMk cId="3675270851" sldId="268"/>
+            <ac:spMk id="3" creationId="{FF53A935-B904-C4D9-10FC-6337C4840FFD}"/>
+          </ac:spMkLst>
+        </pc:spChg>
+        <pc:picChg chg="add">
+          <ac:chgData name="Alex Casson" userId="53cffa54-f866-4b4c-8e51-0383f28edfe1" providerId="ADAL" clId="{7D97CB1E-4F7A-4B5D-BAC2-AE8954581E6E}" dt="2025-06-24T12:55:32.612" v="279" actId="22"/>
+          <ac:picMkLst>
+            <pc:docMk/>
+            <pc:sldMk cId="3675270851" sldId="268"/>
+            <ac:picMk id="5" creationId="{989A8163-A8B1-0E0E-DE5C-5829292FA313}"/>
+          </ac:picMkLst>
+        </pc:picChg>
+      </pc:sldChg>
+      <pc:sldChg chg="addSp delSp modSp new mod">
+        <pc:chgData name="Alex Casson" userId="53cffa54-f866-4b4c-8e51-0383f28edfe1" providerId="ADAL" clId="{7D97CB1E-4F7A-4B5D-BAC2-AE8954581E6E}" dt="2025-06-24T15:58:58.577" v="286" actId="14100"/>
+        <pc:sldMkLst>
+          <pc:docMk/>
+          <pc:sldMk cId="1946310147" sldId="269"/>
+        </pc:sldMkLst>
+        <pc:spChg chg="del">
+          <ac:chgData name="Alex Casson" userId="53cffa54-f866-4b4c-8e51-0383f28edfe1" providerId="ADAL" clId="{7D97CB1E-4F7A-4B5D-BAC2-AE8954581E6E}" dt="2025-06-24T12:58:01.844" v="282" actId="478"/>
+          <ac:spMkLst>
+            <pc:docMk/>
+            <pc:sldMk cId="1946310147" sldId="269"/>
+            <ac:spMk id="2" creationId="{ED3243DC-EA5A-DC2C-3C47-DD1CDBB1BEAD}"/>
+          </ac:spMkLst>
+        </pc:spChg>
+        <pc:spChg chg="del">
+          <ac:chgData name="Alex Casson" userId="53cffa54-f866-4b4c-8e51-0383f28edfe1" providerId="ADAL" clId="{7D97CB1E-4F7A-4B5D-BAC2-AE8954581E6E}" dt="2025-06-24T12:58:01.240" v="281" actId="478"/>
+          <ac:spMkLst>
+            <pc:docMk/>
+            <pc:sldMk cId="1946310147" sldId="269"/>
+            <ac:spMk id="3" creationId="{00924603-EF7E-62C7-74D4-16229F9E35AC}"/>
+          </ac:spMkLst>
+        </pc:spChg>
+        <pc:spChg chg="add mod">
+          <ac:chgData name="Alex Casson" userId="53cffa54-f866-4b4c-8e51-0383f28edfe1" providerId="ADAL" clId="{7D97CB1E-4F7A-4B5D-BAC2-AE8954581E6E}" dt="2025-06-24T15:58:58.577" v="286" actId="14100"/>
+          <ac:spMkLst>
+            <pc:docMk/>
+            <pc:sldMk cId="1946310147" sldId="269"/>
+            <ac:spMk id="6" creationId="{5781A8F1-6C0F-C8BC-A412-409D8ACF4880}"/>
+          </ac:spMkLst>
+        </pc:spChg>
+        <pc:picChg chg="add">
+          <ac:chgData name="Alex Casson" userId="53cffa54-f866-4b4c-8e51-0383f28edfe1" providerId="ADAL" clId="{7D97CB1E-4F7A-4B5D-BAC2-AE8954581E6E}" dt="2025-06-24T12:58:02.690" v="283" actId="22"/>
+          <ac:picMkLst>
+            <pc:docMk/>
+            <pc:sldMk cId="1946310147" sldId="269"/>
+            <ac:picMk id="5" creationId="{6A03D067-EAF3-C3A1-743B-552569E1A05C}"/>
+          </ac:picMkLst>
+        </pc:picChg>
+      </pc:sldChg>
+      <pc:sldChg chg="addSp delSp modSp new mod">
+        <pc:chgData name="Alex Casson" userId="53cffa54-f866-4b4c-8e51-0383f28edfe1" providerId="ADAL" clId="{7D97CB1E-4F7A-4B5D-BAC2-AE8954581E6E}" dt="2025-06-24T16:02:16.623" v="293" actId="14100"/>
+        <pc:sldMkLst>
+          <pc:docMk/>
+          <pc:sldMk cId="1137329714" sldId="270"/>
+        </pc:sldMkLst>
+        <pc:spChg chg="del">
+          <ac:chgData name="Alex Casson" userId="53cffa54-f866-4b4c-8e51-0383f28edfe1" providerId="ADAL" clId="{7D97CB1E-4F7A-4B5D-BAC2-AE8954581E6E}" dt="2025-06-24T16:01:56.648" v="289" actId="478"/>
+          <ac:spMkLst>
+            <pc:docMk/>
+            <pc:sldMk cId="1137329714" sldId="270"/>
+            <ac:spMk id="2" creationId="{AA235A85-A210-7405-6184-F3FDD5038926}"/>
+          </ac:spMkLst>
+        </pc:spChg>
+        <pc:spChg chg="del">
+          <ac:chgData name="Alex Casson" userId="53cffa54-f866-4b4c-8e51-0383f28edfe1" providerId="ADAL" clId="{7D97CB1E-4F7A-4B5D-BAC2-AE8954581E6E}" dt="2025-06-24T16:01:56.106" v="288" actId="478"/>
+          <ac:spMkLst>
+            <pc:docMk/>
+            <pc:sldMk cId="1137329714" sldId="270"/>
+            <ac:spMk id="3" creationId="{48183D3D-D587-31F7-EBAC-F2FA4C035C98}"/>
+          </ac:spMkLst>
+        </pc:spChg>
+        <pc:spChg chg="add mod">
+          <ac:chgData name="Alex Casson" userId="53cffa54-f866-4b4c-8e51-0383f28edfe1" providerId="ADAL" clId="{7D97CB1E-4F7A-4B5D-BAC2-AE8954581E6E}" dt="2025-06-24T16:02:16.623" v="293" actId="14100"/>
+          <ac:spMkLst>
+            <pc:docMk/>
+            <pc:sldMk cId="1137329714" sldId="270"/>
+            <ac:spMk id="6" creationId="{6EC57B4D-5C7F-157D-913C-4CFB87CA586B}"/>
+          </ac:spMkLst>
+        </pc:spChg>
+        <pc:picChg chg="add">
+          <ac:chgData name="Alex Casson" userId="53cffa54-f866-4b4c-8e51-0383f28edfe1" providerId="ADAL" clId="{7D97CB1E-4F7A-4B5D-BAC2-AE8954581E6E}" dt="2025-06-24T16:02:02.898" v="290" actId="22"/>
+          <ac:picMkLst>
+            <pc:docMk/>
+            <pc:sldMk cId="1137329714" sldId="270"/>
+            <ac:picMk id="5" creationId="{AE5FB92C-0164-3FC4-A556-5B1C6A184FC2}"/>
+          </ac:picMkLst>
+        </pc:picChg>
+      </pc:sldChg>
+      <pc:sldChg chg="addSp delSp modSp new mod">
+        <pc:chgData name="Alex Casson" userId="53cffa54-f866-4b4c-8e51-0383f28edfe1" providerId="ADAL" clId="{7D97CB1E-4F7A-4B5D-BAC2-AE8954581E6E}" dt="2025-06-24T16:08:52.225" v="578" actId="20577"/>
+        <pc:sldMkLst>
+          <pc:docMk/>
+          <pc:sldMk cId="1718263740" sldId="271"/>
+        </pc:sldMkLst>
+        <pc:spChg chg="del">
+          <ac:chgData name="Alex Casson" userId="53cffa54-f866-4b4c-8e51-0383f28edfe1" providerId="ADAL" clId="{7D97CB1E-4F7A-4B5D-BAC2-AE8954581E6E}" dt="2025-06-24T16:05:03.331" v="296" actId="478"/>
+          <ac:spMkLst>
+            <pc:docMk/>
+            <pc:sldMk cId="1718263740" sldId="271"/>
+            <ac:spMk id="2" creationId="{561B3B0E-EBA7-687F-C414-106DFA2BE768}"/>
+          </ac:spMkLst>
+        </pc:spChg>
+        <pc:spChg chg="del">
+          <ac:chgData name="Alex Casson" userId="53cffa54-f866-4b4c-8e51-0383f28edfe1" providerId="ADAL" clId="{7D97CB1E-4F7A-4B5D-BAC2-AE8954581E6E}" dt="2025-06-24T16:05:02.361" v="295" actId="478"/>
+          <ac:spMkLst>
+            <pc:docMk/>
+            <pc:sldMk cId="1718263740" sldId="271"/>
+            <ac:spMk id="3" creationId="{23DDC6BA-C870-3FC6-1DE3-C2AE0A9264A4}"/>
+          </ac:spMkLst>
+        </pc:spChg>
+        <pc:spChg chg="add mod">
+          <ac:chgData name="Alex Casson" userId="53cffa54-f866-4b4c-8e51-0383f28edfe1" providerId="ADAL" clId="{7D97CB1E-4F7A-4B5D-BAC2-AE8954581E6E}" dt="2025-06-24T16:05:19.090" v="302" actId="14100"/>
+          <ac:spMkLst>
+            <pc:docMk/>
+            <pc:sldMk cId="1718263740" sldId="271"/>
+            <ac:spMk id="6" creationId="{4FB02F4D-9CB3-04ED-96AD-7AFFD2242948}"/>
+          </ac:spMkLst>
+        </pc:spChg>
+        <pc:spChg chg="add mod">
+          <ac:chgData name="Alex Casson" userId="53cffa54-f866-4b4c-8e51-0383f28edfe1" providerId="ADAL" clId="{7D97CB1E-4F7A-4B5D-BAC2-AE8954581E6E}" dt="2025-06-24T16:06:07.423" v="404" actId="1076"/>
+          <ac:spMkLst>
+            <pc:docMk/>
+            <pc:sldMk cId="1718263740" sldId="271"/>
+            <ac:spMk id="7" creationId="{1CDB2DD8-59A9-AB93-0A20-F96FA87F1979}"/>
+          </ac:spMkLst>
+        </pc:spChg>
+        <pc:spChg chg="add mod">
+          <ac:chgData name="Alex Casson" userId="53cffa54-f866-4b4c-8e51-0383f28edfe1" providerId="ADAL" clId="{7D97CB1E-4F7A-4B5D-BAC2-AE8954581E6E}" dt="2025-06-24T16:06:03.008" v="403" actId="14100"/>
+          <ac:spMkLst>
+            <pc:docMk/>
+            <pc:sldMk cId="1718263740" sldId="271"/>
+            <ac:spMk id="8" creationId="{E7B02875-C3AE-1741-37D5-D6A0219E8362}"/>
+          </ac:spMkLst>
+        </pc:spChg>
+        <pc:spChg chg="add mod">
+          <ac:chgData name="Alex Casson" userId="53cffa54-f866-4b4c-8e51-0383f28edfe1" providerId="ADAL" clId="{7D97CB1E-4F7A-4B5D-BAC2-AE8954581E6E}" dt="2025-06-24T16:08:47.430" v="572" actId="1076"/>
+          <ac:spMkLst>
+            <pc:docMk/>
+            <pc:sldMk cId="1718263740" sldId="271"/>
+            <ac:spMk id="9" creationId="{95D48F15-34E2-E1CE-E4A2-7EF24A01EDC8}"/>
+          </ac:spMkLst>
+        </pc:spChg>
+        <pc:spChg chg="add mod">
+          <ac:chgData name="Alex Casson" userId="53cffa54-f866-4b4c-8e51-0383f28edfe1" providerId="ADAL" clId="{7D97CB1E-4F7A-4B5D-BAC2-AE8954581E6E}" dt="2025-06-24T16:08:49.321" v="575" actId="20577"/>
+          <ac:spMkLst>
+            <pc:docMk/>
+            <pc:sldMk cId="1718263740" sldId="271"/>
+            <ac:spMk id="10" creationId="{14334E4B-5D4A-2EEB-32D9-979DF57C033C}"/>
+          </ac:spMkLst>
+        </pc:spChg>
+        <pc:spChg chg="add mod">
+          <ac:chgData name="Alex Casson" userId="53cffa54-f866-4b4c-8e51-0383f28edfe1" providerId="ADAL" clId="{7D97CB1E-4F7A-4B5D-BAC2-AE8954581E6E}" dt="2025-06-24T16:06:52.890" v="441" actId="14100"/>
+          <ac:spMkLst>
+            <pc:docMk/>
+            <pc:sldMk cId="1718263740" sldId="271"/>
+            <ac:spMk id="11" creationId="{AAFBCCF6-D9A6-8669-548B-9278E48A70AA}"/>
+          </ac:spMkLst>
+        </pc:spChg>
+        <pc:spChg chg="add mod">
+          <ac:chgData name="Alex Casson" userId="53cffa54-f866-4b4c-8e51-0383f28edfe1" providerId="ADAL" clId="{7D97CB1E-4F7A-4B5D-BAC2-AE8954581E6E}" dt="2025-06-24T16:08:52.225" v="578" actId="20577"/>
+          <ac:spMkLst>
+            <pc:docMk/>
+            <pc:sldMk cId="1718263740" sldId="271"/>
+            <ac:spMk id="12" creationId="{9252911D-1C32-2E70-C194-60BEB48A497C}"/>
+          </ac:spMkLst>
+        </pc:spChg>
+        <pc:picChg chg="add mod">
+          <ac:chgData name="Alex Casson" userId="53cffa54-f866-4b4c-8e51-0383f28edfe1" providerId="ADAL" clId="{7D97CB1E-4F7A-4B5D-BAC2-AE8954581E6E}" dt="2025-06-24T16:06:25.530" v="410" actId="1076"/>
+          <ac:picMkLst>
+            <pc:docMk/>
+            <pc:sldMk cId="1718263740" sldId="271"/>
+            <ac:picMk id="5" creationId="{94BB17E5-51ED-3EAC-4716-AA5BC85B6547}"/>
+          </ac:picMkLst>
+        </pc:picChg>
+      </pc:sldChg>
+      <pc:sldChg chg="addSp delSp modSp new mod">
+        <pc:chgData name="Alex Casson" userId="53cffa54-f866-4b4c-8e51-0383f28edfe1" providerId="ADAL" clId="{7D97CB1E-4F7A-4B5D-BAC2-AE8954581E6E}" dt="2025-06-24T16:21:33.884" v="654" actId="14100"/>
+        <pc:sldMkLst>
+          <pc:docMk/>
+          <pc:sldMk cId="2323277968" sldId="272"/>
+        </pc:sldMkLst>
+        <pc:spChg chg="del">
+          <ac:chgData name="Alex Casson" userId="53cffa54-f866-4b4c-8e51-0383f28edfe1" providerId="ADAL" clId="{7D97CB1E-4F7A-4B5D-BAC2-AE8954581E6E}" dt="2025-06-24T16:20:17.480" v="580" actId="478"/>
+          <ac:spMkLst>
+            <pc:docMk/>
+            <pc:sldMk cId="2323277968" sldId="272"/>
+            <ac:spMk id="2" creationId="{0F9AA2C1-C75B-E898-9CEF-C80700A4E6A9}"/>
+          </ac:spMkLst>
+        </pc:spChg>
+        <pc:spChg chg="del">
+          <ac:chgData name="Alex Casson" userId="53cffa54-f866-4b4c-8e51-0383f28edfe1" providerId="ADAL" clId="{7D97CB1E-4F7A-4B5D-BAC2-AE8954581E6E}" dt="2025-06-24T16:20:18.097" v="581" actId="478"/>
+          <ac:spMkLst>
+            <pc:docMk/>
+            <pc:sldMk cId="2323277968" sldId="272"/>
+            <ac:spMk id="3" creationId="{F24BCD37-9886-FB9E-F3D7-145EEE41CBC5}"/>
+          </ac:spMkLst>
+        </pc:spChg>
+        <pc:spChg chg="add mod">
+          <ac:chgData name="Alex Casson" userId="53cffa54-f866-4b4c-8e51-0383f28edfe1" providerId="ADAL" clId="{7D97CB1E-4F7A-4B5D-BAC2-AE8954581E6E}" dt="2025-06-24T16:20:37.678" v="585" actId="14100"/>
+          <ac:spMkLst>
+            <pc:docMk/>
+            <pc:sldMk cId="2323277968" sldId="272"/>
+            <ac:spMk id="6" creationId="{AB2D4920-9A0D-E96E-C393-31C5CC6A1E54}"/>
+          </ac:spMkLst>
+        </pc:spChg>
+        <pc:spChg chg="add mod">
+          <ac:chgData name="Alex Casson" userId="53cffa54-f866-4b4c-8e51-0383f28edfe1" providerId="ADAL" clId="{7D97CB1E-4F7A-4B5D-BAC2-AE8954581E6E}" dt="2025-06-24T16:20:54.588" v="619" actId="1076"/>
+          <ac:spMkLst>
+            <pc:docMk/>
+            <pc:sldMk cId="2323277968" sldId="272"/>
+            <ac:spMk id="7" creationId="{3D3272D1-0FF4-0A94-86FE-5387CF2D3A21}"/>
+          </ac:spMkLst>
+        </pc:spChg>
+        <pc:spChg chg="add mod">
+          <ac:chgData name="Alex Casson" userId="53cffa54-f866-4b4c-8e51-0383f28edfe1" providerId="ADAL" clId="{7D97CB1E-4F7A-4B5D-BAC2-AE8954581E6E}" dt="2025-06-24T16:21:17.560" v="626" actId="14100"/>
+          <ac:spMkLst>
+            <pc:docMk/>
+            <pc:sldMk cId="2323277968" sldId="272"/>
+            <ac:spMk id="8" creationId="{EF9DF620-C602-9D2F-902D-CD25207C2CAE}"/>
+          </ac:spMkLst>
+        </pc:spChg>
+        <pc:spChg chg="add mod">
+          <ac:chgData name="Alex Casson" userId="53cffa54-f866-4b4c-8e51-0383f28edfe1" providerId="ADAL" clId="{7D97CB1E-4F7A-4B5D-BAC2-AE8954581E6E}" dt="2025-06-24T16:21:33.884" v="654" actId="14100"/>
+          <ac:spMkLst>
+            <pc:docMk/>
+            <pc:sldMk cId="2323277968" sldId="272"/>
+            <ac:spMk id="9" creationId="{6BC487D4-140A-77D6-45D5-38B6F31EE99D}"/>
+          </ac:spMkLst>
+        </pc:spChg>
+        <pc:picChg chg="add mod">
+          <ac:chgData name="Alex Casson" userId="53cffa54-f866-4b4c-8e51-0383f28edfe1" providerId="ADAL" clId="{7D97CB1E-4F7A-4B5D-BAC2-AE8954581E6E}" dt="2025-06-24T16:21:02.352" v="622" actId="1076"/>
+          <ac:picMkLst>
+            <pc:docMk/>
+            <pc:sldMk cId="2323277968" sldId="272"/>
+            <ac:picMk id="5" creationId="{A76C55FF-D198-AE52-ABE8-2CB06EEB97E3}"/>
           </ac:picMkLst>
         </pc:picChg>
       </pc:sldChg>
@@ -5516,6 +5780,915 @@
     <p:extLst>
       <p:ext uri="{BB962C8B-B14F-4D97-AF65-F5344CB8AC3E}">
         <p14:creationId xmlns:p14="http://schemas.microsoft.com/office/powerpoint/2010/main" val="2381781374"/>
+      </p:ext>
+    </p:extLst>
+  </p:cSld>
+  <p:clrMapOvr>
+    <a:masterClrMapping/>
+  </p:clrMapOvr>
+</p:sld>
+</file>
+
+<file path=ppt/slides/slide13.xml><?xml version="1.0" encoding="utf-8"?>
+<p:sld xmlns:a="http://schemas.openxmlformats.org/drawingml/2006/main" xmlns:r="http://schemas.openxmlformats.org/officeDocument/2006/relationships" xmlns:p="http://schemas.openxmlformats.org/presentationml/2006/main">
+  <p:cSld>
+    <p:spTree>
+      <p:nvGrpSpPr>
+        <p:cNvPr id="1" name=""/>
+        <p:cNvGrpSpPr/>
+        <p:nvPr/>
+      </p:nvGrpSpPr>
+      <p:grpSpPr>
+        <a:xfrm>
+          <a:off x="0" y="0"/>
+          <a:ext cx="0" cy="0"/>
+          <a:chOff x="0" y="0"/>
+          <a:chExt cx="0" cy="0"/>
+        </a:xfrm>
+      </p:grpSpPr>
+      <p:pic>
+        <p:nvPicPr>
+          <p:cNvPr id="5" name="Picture 4">
+            <a:extLst>
+              <a:ext uri="{FF2B5EF4-FFF2-40B4-BE49-F238E27FC236}">
+                <a16:creationId xmlns:a16="http://schemas.microsoft.com/office/drawing/2014/main" id="{989A8163-A8B1-0E0E-DE5C-5829292FA313}"/>
+              </a:ext>
+            </a:extLst>
+          </p:cNvPr>
+          <p:cNvPicPr>
+            <a:picLocks noChangeAspect="1"/>
+          </p:cNvPicPr>
+          <p:nvPr/>
+        </p:nvPicPr>
+        <p:blipFill>
+          <a:blip r:embed="rId2"/>
+          <a:stretch>
+            <a:fillRect/>
+          </a:stretch>
+        </p:blipFill>
+        <p:spPr>
+          <a:xfrm>
+            <a:off x="0" y="303068"/>
+            <a:ext cx="12192000" cy="6251864"/>
+          </a:xfrm>
+          <a:prstGeom prst="rect">
+            <a:avLst/>
+          </a:prstGeom>
+        </p:spPr>
+      </p:pic>
+    </p:spTree>
+    <p:extLst>
+      <p:ext uri="{BB962C8B-B14F-4D97-AF65-F5344CB8AC3E}">
+        <p14:creationId xmlns:p14="http://schemas.microsoft.com/office/powerpoint/2010/main" val="3675270851"/>
+      </p:ext>
+    </p:extLst>
+  </p:cSld>
+  <p:clrMapOvr>
+    <a:masterClrMapping/>
+  </p:clrMapOvr>
+</p:sld>
+</file>
+
+<file path=ppt/slides/slide14.xml><?xml version="1.0" encoding="utf-8"?>
+<p:sld xmlns:a="http://schemas.openxmlformats.org/drawingml/2006/main" xmlns:r="http://schemas.openxmlformats.org/officeDocument/2006/relationships" xmlns:p="http://schemas.openxmlformats.org/presentationml/2006/main">
+  <p:cSld>
+    <p:spTree>
+      <p:nvGrpSpPr>
+        <p:cNvPr id="1" name=""/>
+        <p:cNvGrpSpPr/>
+        <p:nvPr/>
+      </p:nvGrpSpPr>
+      <p:grpSpPr>
+        <a:xfrm>
+          <a:off x="0" y="0"/>
+          <a:ext cx="0" cy="0"/>
+          <a:chOff x="0" y="0"/>
+          <a:chExt cx="0" cy="0"/>
+        </a:xfrm>
+      </p:grpSpPr>
+      <p:pic>
+        <p:nvPicPr>
+          <p:cNvPr id="5" name="Picture 4">
+            <a:extLst>
+              <a:ext uri="{FF2B5EF4-FFF2-40B4-BE49-F238E27FC236}">
+                <a16:creationId xmlns:a16="http://schemas.microsoft.com/office/drawing/2014/main" id="{6A03D067-EAF3-C3A1-743B-552569E1A05C}"/>
+              </a:ext>
+            </a:extLst>
+          </p:cNvPr>
+          <p:cNvPicPr>
+            <a:picLocks noChangeAspect="1"/>
+          </p:cNvPicPr>
+          <p:nvPr/>
+        </p:nvPicPr>
+        <p:blipFill>
+          <a:blip r:embed="rId2"/>
+          <a:stretch>
+            <a:fillRect/>
+          </a:stretch>
+        </p:blipFill>
+        <p:spPr>
+          <a:xfrm>
+            <a:off x="952500" y="0"/>
+            <a:ext cx="10287000" cy="6858000"/>
+          </a:xfrm>
+          <a:prstGeom prst="rect">
+            <a:avLst/>
+          </a:prstGeom>
+        </p:spPr>
+      </p:pic>
+      <p:sp>
+        <p:nvSpPr>
+          <p:cNvPr id="6" name="Rectangle 5">
+            <a:extLst>
+              <a:ext uri="{FF2B5EF4-FFF2-40B4-BE49-F238E27FC236}">
+                <a16:creationId xmlns:a16="http://schemas.microsoft.com/office/drawing/2014/main" id="{5781A8F1-6C0F-C8BC-A412-409D8ACF4880}"/>
+              </a:ext>
+            </a:extLst>
+          </p:cNvPr>
+          <p:cNvSpPr/>
+          <p:nvPr/>
+        </p:nvSpPr>
+        <p:spPr>
+          <a:xfrm>
+            <a:off x="2171387" y="2965957"/>
+            <a:ext cx="1583490" cy="244172"/>
+          </a:xfrm>
+          <a:prstGeom prst="rect">
+            <a:avLst/>
+          </a:prstGeom>
+          <a:noFill/>
+          <a:ln w="28575">
+            <a:solidFill>
+              <a:srgbClr val="C00000"/>
+            </a:solidFill>
+          </a:ln>
+        </p:spPr>
+        <p:style>
+          <a:lnRef idx="2">
+            <a:schemeClr val="accent1">
+              <a:shade val="15000"/>
+            </a:schemeClr>
+          </a:lnRef>
+          <a:fillRef idx="1">
+            <a:schemeClr val="accent1"/>
+          </a:fillRef>
+          <a:effectRef idx="0">
+            <a:schemeClr val="accent1"/>
+          </a:effectRef>
+          <a:fontRef idx="minor">
+            <a:schemeClr val="lt1"/>
+          </a:fontRef>
+        </p:style>
+        <p:txBody>
+          <a:bodyPr rtlCol="0" anchor="ctr"/>
+          <a:lstStyle/>
+          <a:p>
+            <a:pPr algn="ctr"/>
+            <a:endParaRPr lang="en-GB"/>
+          </a:p>
+        </p:txBody>
+      </p:sp>
+    </p:spTree>
+    <p:extLst>
+      <p:ext uri="{BB962C8B-B14F-4D97-AF65-F5344CB8AC3E}">
+        <p14:creationId xmlns:p14="http://schemas.microsoft.com/office/powerpoint/2010/main" val="1946310147"/>
+      </p:ext>
+    </p:extLst>
+  </p:cSld>
+  <p:clrMapOvr>
+    <a:masterClrMapping/>
+  </p:clrMapOvr>
+</p:sld>
+</file>
+
+<file path=ppt/slides/slide15.xml><?xml version="1.0" encoding="utf-8"?>
+<p:sld xmlns:a="http://schemas.openxmlformats.org/drawingml/2006/main" xmlns:r="http://schemas.openxmlformats.org/officeDocument/2006/relationships" xmlns:p="http://schemas.openxmlformats.org/presentationml/2006/main">
+  <p:cSld>
+    <p:spTree>
+      <p:nvGrpSpPr>
+        <p:cNvPr id="1" name=""/>
+        <p:cNvGrpSpPr/>
+        <p:nvPr/>
+      </p:nvGrpSpPr>
+      <p:grpSpPr>
+        <a:xfrm>
+          <a:off x="0" y="0"/>
+          <a:ext cx="0" cy="0"/>
+          <a:chOff x="0" y="0"/>
+          <a:chExt cx="0" cy="0"/>
+        </a:xfrm>
+      </p:grpSpPr>
+      <p:pic>
+        <p:nvPicPr>
+          <p:cNvPr id="5" name="Picture 4">
+            <a:extLst>
+              <a:ext uri="{FF2B5EF4-FFF2-40B4-BE49-F238E27FC236}">
+                <a16:creationId xmlns:a16="http://schemas.microsoft.com/office/drawing/2014/main" id="{AE5FB92C-0164-3FC4-A556-5B1C6A184FC2}"/>
+              </a:ext>
+            </a:extLst>
+          </p:cNvPr>
+          <p:cNvPicPr>
+            <a:picLocks noChangeAspect="1"/>
+          </p:cNvPicPr>
+          <p:nvPr/>
+        </p:nvPicPr>
+        <p:blipFill>
+          <a:blip r:embed="rId2"/>
+          <a:stretch>
+            <a:fillRect/>
+          </a:stretch>
+        </p:blipFill>
+        <p:spPr>
+          <a:xfrm>
+            <a:off x="952500" y="0"/>
+            <a:ext cx="10287000" cy="6858000"/>
+          </a:xfrm>
+          <a:prstGeom prst="rect">
+            <a:avLst/>
+          </a:prstGeom>
+        </p:spPr>
+      </p:pic>
+      <p:sp>
+        <p:nvSpPr>
+          <p:cNvPr id="6" name="Rectangle 5">
+            <a:extLst>
+              <a:ext uri="{FF2B5EF4-FFF2-40B4-BE49-F238E27FC236}">
+                <a16:creationId xmlns:a16="http://schemas.microsoft.com/office/drawing/2014/main" id="{6EC57B4D-5C7F-157D-913C-4CFB87CA586B}"/>
+              </a:ext>
+            </a:extLst>
+          </p:cNvPr>
+          <p:cNvSpPr/>
+          <p:nvPr/>
+        </p:nvSpPr>
+        <p:spPr>
+          <a:xfrm>
+            <a:off x="4603301" y="4454288"/>
+            <a:ext cx="1836409" cy="341447"/>
+          </a:xfrm>
+          <a:prstGeom prst="rect">
+            <a:avLst/>
+          </a:prstGeom>
+          <a:noFill/>
+          <a:ln w="28575">
+            <a:solidFill>
+              <a:srgbClr val="C00000"/>
+            </a:solidFill>
+          </a:ln>
+        </p:spPr>
+        <p:style>
+          <a:lnRef idx="2">
+            <a:schemeClr val="accent1">
+              <a:shade val="15000"/>
+            </a:schemeClr>
+          </a:lnRef>
+          <a:fillRef idx="1">
+            <a:schemeClr val="accent1"/>
+          </a:fillRef>
+          <a:effectRef idx="0">
+            <a:schemeClr val="accent1"/>
+          </a:effectRef>
+          <a:fontRef idx="minor">
+            <a:schemeClr val="lt1"/>
+          </a:fontRef>
+        </p:style>
+        <p:txBody>
+          <a:bodyPr rtlCol="0" anchor="ctr"/>
+          <a:lstStyle/>
+          <a:p>
+            <a:pPr algn="ctr"/>
+            <a:endParaRPr lang="en-GB"/>
+          </a:p>
+        </p:txBody>
+      </p:sp>
+    </p:spTree>
+    <p:extLst>
+      <p:ext uri="{BB962C8B-B14F-4D97-AF65-F5344CB8AC3E}">
+        <p14:creationId xmlns:p14="http://schemas.microsoft.com/office/powerpoint/2010/main" val="1137329714"/>
+      </p:ext>
+    </p:extLst>
+  </p:cSld>
+  <p:clrMapOvr>
+    <a:masterClrMapping/>
+  </p:clrMapOvr>
+</p:sld>
+</file>
+
+<file path=ppt/slides/slide16.xml><?xml version="1.0" encoding="utf-8"?>
+<p:sld xmlns:a="http://schemas.openxmlformats.org/drawingml/2006/main" xmlns:r="http://schemas.openxmlformats.org/officeDocument/2006/relationships" xmlns:p="http://schemas.openxmlformats.org/presentationml/2006/main">
+  <p:cSld>
+    <p:spTree>
+      <p:nvGrpSpPr>
+        <p:cNvPr id="1" name=""/>
+        <p:cNvGrpSpPr/>
+        <p:nvPr/>
+      </p:nvGrpSpPr>
+      <p:grpSpPr>
+        <a:xfrm>
+          <a:off x="0" y="0"/>
+          <a:ext cx="0" cy="0"/>
+          <a:chOff x="0" y="0"/>
+          <a:chExt cx="0" cy="0"/>
+        </a:xfrm>
+      </p:grpSpPr>
+      <p:pic>
+        <p:nvPicPr>
+          <p:cNvPr id="5" name="Picture 4">
+            <a:extLst>
+              <a:ext uri="{FF2B5EF4-FFF2-40B4-BE49-F238E27FC236}">
+                <a16:creationId xmlns:a16="http://schemas.microsoft.com/office/drawing/2014/main" id="{94BB17E5-51ED-3EAC-4716-AA5BC85B6547}"/>
+              </a:ext>
+            </a:extLst>
+          </p:cNvPr>
+          <p:cNvPicPr>
+            <a:picLocks noChangeAspect="1"/>
+          </p:cNvPicPr>
+          <p:nvPr/>
+        </p:nvPicPr>
+        <p:blipFill>
+          <a:blip r:embed="rId2"/>
+          <a:stretch>
+            <a:fillRect/>
+          </a:stretch>
+        </p:blipFill>
+        <p:spPr>
+          <a:xfrm>
+            <a:off x="952500" y="0"/>
+            <a:ext cx="10287000" cy="6858000"/>
+          </a:xfrm>
+          <a:prstGeom prst="rect">
+            <a:avLst/>
+          </a:prstGeom>
+        </p:spPr>
+      </p:pic>
+      <p:sp>
+        <p:nvSpPr>
+          <p:cNvPr id="6" name="Rectangle 5">
+            <a:extLst>
+              <a:ext uri="{FF2B5EF4-FFF2-40B4-BE49-F238E27FC236}">
+                <a16:creationId xmlns:a16="http://schemas.microsoft.com/office/drawing/2014/main" id="{4FB02F4D-9CB3-04ED-96AD-7AFFD2242948}"/>
+              </a:ext>
+            </a:extLst>
+          </p:cNvPr>
+          <p:cNvSpPr/>
+          <p:nvPr/>
+        </p:nvSpPr>
+        <p:spPr>
+          <a:xfrm>
+            <a:off x="1315353" y="553497"/>
+            <a:ext cx="639907" cy="263626"/>
+          </a:xfrm>
+          <a:prstGeom prst="rect">
+            <a:avLst/>
+          </a:prstGeom>
+          <a:noFill/>
+          <a:ln w="28575">
+            <a:solidFill>
+              <a:srgbClr val="C00000"/>
+            </a:solidFill>
+          </a:ln>
+        </p:spPr>
+        <p:style>
+          <a:lnRef idx="2">
+            <a:schemeClr val="accent1">
+              <a:shade val="15000"/>
+            </a:schemeClr>
+          </a:lnRef>
+          <a:fillRef idx="1">
+            <a:schemeClr val="accent1"/>
+          </a:fillRef>
+          <a:effectRef idx="0">
+            <a:schemeClr val="accent1"/>
+          </a:effectRef>
+          <a:fontRef idx="minor">
+            <a:schemeClr val="lt1"/>
+          </a:fontRef>
+        </p:style>
+        <p:txBody>
+          <a:bodyPr rtlCol="0" anchor="ctr"/>
+          <a:lstStyle/>
+          <a:p>
+            <a:pPr algn="ctr"/>
+            <a:endParaRPr lang="en-GB"/>
+          </a:p>
+        </p:txBody>
+      </p:sp>
+      <p:sp>
+        <p:nvSpPr>
+          <p:cNvPr id="7" name="TextBox 6">
+            <a:extLst>
+              <a:ext uri="{FF2B5EF4-FFF2-40B4-BE49-F238E27FC236}">
+                <a16:creationId xmlns:a16="http://schemas.microsoft.com/office/drawing/2014/main" id="{1CDB2DD8-59A9-AB93-0A20-F96FA87F1979}"/>
+              </a:ext>
+            </a:extLst>
+          </p:cNvPr>
+          <p:cNvSpPr txBox="1"/>
+          <p:nvPr/>
+        </p:nvSpPr>
+        <p:spPr>
+          <a:xfrm>
+            <a:off x="1955260" y="456220"/>
+            <a:ext cx="1429966" cy="1200329"/>
+          </a:xfrm>
+          <a:prstGeom prst="rect">
+            <a:avLst/>
+          </a:prstGeom>
+          <a:noFill/>
+        </p:spPr>
+        <p:txBody>
+          <a:bodyPr wrap="square" rtlCol="0">
+            <a:spAutoFit/>
+          </a:bodyPr>
+          <a:lstStyle/>
+          <a:p>
+            <a:r>
+              <a:rPr lang="en-GB" dirty="0">
+                <a:solidFill>
+                  <a:srgbClr val="C00000"/>
+                </a:solidFill>
+              </a:rPr>
+              <a:t>Name of the folder that’s been opened</a:t>
+            </a:r>
+          </a:p>
+        </p:txBody>
+      </p:sp>
+      <p:sp>
+        <p:nvSpPr>
+          <p:cNvPr id="8" name="TextBox 7">
+            <a:extLst>
+              <a:ext uri="{FF2B5EF4-FFF2-40B4-BE49-F238E27FC236}">
+                <a16:creationId xmlns:a16="http://schemas.microsoft.com/office/drawing/2014/main" id="{E7B02875-C3AE-1741-37D5-D6A0219E8362}"/>
+              </a:ext>
+            </a:extLst>
+          </p:cNvPr>
+          <p:cNvSpPr txBox="1"/>
+          <p:nvPr/>
+        </p:nvSpPr>
+        <p:spPr>
+          <a:xfrm>
+            <a:off x="1315353" y="1845658"/>
+            <a:ext cx="2069873" cy="923330"/>
+          </a:xfrm>
+          <a:prstGeom prst="rect">
+            <a:avLst/>
+          </a:prstGeom>
+          <a:noFill/>
+        </p:spPr>
+        <p:txBody>
+          <a:bodyPr wrap="square" rtlCol="0">
+            <a:spAutoFit/>
+          </a:bodyPr>
+          <a:lstStyle/>
+          <a:p>
+            <a:r>
+              <a:rPr lang="en-GB" dirty="0">
+                <a:solidFill>
+                  <a:srgbClr val="C00000"/>
+                </a:solidFill>
+              </a:rPr>
+              <a:t>Files in the folder (if any) will appear here</a:t>
+            </a:r>
+          </a:p>
+        </p:txBody>
+      </p:sp>
+      <p:sp>
+        <p:nvSpPr>
+          <p:cNvPr id="9" name="Rectangle 8">
+            <a:extLst>
+              <a:ext uri="{FF2B5EF4-FFF2-40B4-BE49-F238E27FC236}">
+                <a16:creationId xmlns:a16="http://schemas.microsoft.com/office/drawing/2014/main" id="{95D48F15-34E2-E1CE-E4A2-7EF24A01EDC8}"/>
+              </a:ext>
+            </a:extLst>
+          </p:cNvPr>
+          <p:cNvSpPr/>
+          <p:nvPr/>
+        </p:nvSpPr>
+        <p:spPr>
+          <a:xfrm>
+            <a:off x="4055311" y="2399656"/>
+            <a:ext cx="1022528" cy="339489"/>
+          </a:xfrm>
+          <a:prstGeom prst="rect">
+            <a:avLst/>
+          </a:prstGeom>
+          <a:noFill/>
+          <a:ln w="28575">
+            <a:solidFill>
+              <a:srgbClr val="C00000"/>
+            </a:solidFill>
+          </a:ln>
+        </p:spPr>
+        <p:style>
+          <a:lnRef idx="2">
+            <a:schemeClr val="accent1">
+              <a:shade val="15000"/>
+            </a:schemeClr>
+          </a:lnRef>
+          <a:fillRef idx="1">
+            <a:schemeClr val="accent1"/>
+          </a:fillRef>
+          <a:effectRef idx="0">
+            <a:schemeClr val="accent1"/>
+          </a:effectRef>
+          <a:fontRef idx="minor">
+            <a:schemeClr val="lt1"/>
+          </a:fontRef>
+        </p:style>
+        <p:txBody>
+          <a:bodyPr rtlCol="0" anchor="ctr"/>
+          <a:lstStyle/>
+          <a:p>
+            <a:pPr algn="ctr"/>
+            <a:endParaRPr lang="en-GB"/>
+          </a:p>
+        </p:txBody>
+      </p:sp>
+      <p:sp>
+        <p:nvSpPr>
+          <p:cNvPr id="10" name="TextBox 9">
+            <a:extLst>
+              <a:ext uri="{FF2B5EF4-FFF2-40B4-BE49-F238E27FC236}">
+                <a16:creationId xmlns:a16="http://schemas.microsoft.com/office/drawing/2014/main" id="{14334E4B-5D4A-2EEB-32D9-979DF57C033C}"/>
+              </a:ext>
+            </a:extLst>
+          </p:cNvPr>
+          <p:cNvSpPr txBox="1"/>
+          <p:nvPr/>
+        </p:nvSpPr>
+        <p:spPr>
+          <a:xfrm>
+            <a:off x="5094457" y="2399656"/>
+            <a:ext cx="2201288" cy="369332"/>
+          </a:xfrm>
+          <a:prstGeom prst="rect">
+            <a:avLst/>
+          </a:prstGeom>
+          <a:noFill/>
+        </p:spPr>
+        <p:txBody>
+          <a:bodyPr wrap="square" rtlCol="0">
+            <a:spAutoFit/>
+          </a:bodyPr>
+          <a:lstStyle/>
+          <a:p>
+            <a:r>
+              <a:rPr lang="en-GB" dirty="0">
+                <a:solidFill>
+                  <a:srgbClr val="C00000"/>
+                </a:solidFill>
+              </a:rPr>
+              <a:t>1. Click New File…</a:t>
+            </a:r>
+          </a:p>
+        </p:txBody>
+      </p:sp>
+      <p:sp>
+        <p:nvSpPr>
+          <p:cNvPr id="11" name="Rectangle 10">
+            <a:extLst>
+              <a:ext uri="{FF2B5EF4-FFF2-40B4-BE49-F238E27FC236}">
+                <a16:creationId xmlns:a16="http://schemas.microsoft.com/office/drawing/2014/main" id="{AAFBCCF6-D9A6-8669-548B-9278E48A70AA}"/>
+              </a:ext>
+            </a:extLst>
+          </p:cNvPr>
+          <p:cNvSpPr/>
+          <p:nvPr/>
+        </p:nvSpPr>
+        <p:spPr>
+          <a:xfrm>
+            <a:off x="3513869" y="214009"/>
+            <a:ext cx="1022528" cy="411955"/>
+          </a:xfrm>
+          <a:prstGeom prst="rect">
+            <a:avLst/>
+          </a:prstGeom>
+          <a:noFill/>
+          <a:ln w="28575">
+            <a:solidFill>
+              <a:srgbClr val="C00000"/>
+            </a:solidFill>
+          </a:ln>
+        </p:spPr>
+        <p:style>
+          <a:lnRef idx="2">
+            <a:schemeClr val="accent1">
+              <a:shade val="15000"/>
+            </a:schemeClr>
+          </a:lnRef>
+          <a:fillRef idx="1">
+            <a:schemeClr val="accent1"/>
+          </a:fillRef>
+          <a:effectRef idx="0">
+            <a:schemeClr val="accent1"/>
+          </a:effectRef>
+          <a:fontRef idx="minor">
+            <a:schemeClr val="lt1"/>
+          </a:fontRef>
+        </p:style>
+        <p:txBody>
+          <a:bodyPr rtlCol="0" anchor="ctr"/>
+          <a:lstStyle/>
+          <a:p>
+            <a:pPr algn="ctr"/>
+            <a:endParaRPr lang="en-GB"/>
+          </a:p>
+        </p:txBody>
+      </p:sp>
+      <p:sp>
+        <p:nvSpPr>
+          <p:cNvPr id="12" name="TextBox 11">
+            <a:extLst>
+              <a:ext uri="{FF2B5EF4-FFF2-40B4-BE49-F238E27FC236}">
+                <a16:creationId xmlns:a16="http://schemas.microsoft.com/office/drawing/2014/main" id="{9252911D-1C32-2E70-C194-60BEB48A497C}"/>
+              </a:ext>
+            </a:extLst>
+          </p:cNvPr>
+          <p:cNvSpPr txBox="1"/>
+          <p:nvPr/>
+        </p:nvSpPr>
+        <p:spPr>
+          <a:xfrm>
+            <a:off x="4516628" y="235320"/>
+            <a:ext cx="6631270" cy="646331"/>
+          </a:xfrm>
+          <a:prstGeom prst="rect">
+            <a:avLst/>
+          </a:prstGeom>
+          <a:noFill/>
+        </p:spPr>
+        <p:txBody>
+          <a:bodyPr wrap="square" rtlCol="0">
+            <a:spAutoFit/>
+          </a:bodyPr>
+          <a:lstStyle/>
+          <a:p>
+            <a:r>
+              <a:rPr lang="en-GB" dirty="0">
+                <a:solidFill>
+                  <a:srgbClr val="C00000"/>
+                </a:solidFill>
+              </a:rPr>
+              <a:t>2. Enter file name here (it will appear after you click New File…)</a:t>
+            </a:r>
+          </a:p>
+          <a:p>
+            <a:r>
+              <a:rPr lang="en-GB" dirty="0">
+                <a:solidFill>
+                  <a:srgbClr val="C00000"/>
+                </a:solidFill>
+              </a:rPr>
+              <a:t>                   Remember to include the extension</a:t>
+            </a:r>
+          </a:p>
+        </p:txBody>
+      </p:sp>
+    </p:spTree>
+    <p:extLst>
+      <p:ext uri="{BB962C8B-B14F-4D97-AF65-F5344CB8AC3E}">
+        <p14:creationId xmlns:p14="http://schemas.microsoft.com/office/powerpoint/2010/main" val="1718263740"/>
+      </p:ext>
+    </p:extLst>
+  </p:cSld>
+  <p:clrMapOvr>
+    <a:masterClrMapping/>
+  </p:clrMapOvr>
+</p:sld>
+</file>
+
+<file path=ppt/slides/slide17.xml><?xml version="1.0" encoding="utf-8"?>
+<p:sld xmlns:a="http://schemas.openxmlformats.org/drawingml/2006/main" xmlns:r="http://schemas.openxmlformats.org/officeDocument/2006/relationships" xmlns:p="http://schemas.openxmlformats.org/presentationml/2006/main">
+  <p:cSld>
+    <p:spTree>
+      <p:nvGrpSpPr>
+        <p:cNvPr id="1" name=""/>
+        <p:cNvGrpSpPr/>
+        <p:nvPr/>
+      </p:nvGrpSpPr>
+      <p:grpSpPr>
+        <a:xfrm>
+          <a:off x="0" y="0"/>
+          <a:ext cx="0" cy="0"/>
+          <a:chOff x="0" y="0"/>
+          <a:chExt cx="0" cy="0"/>
+        </a:xfrm>
+      </p:grpSpPr>
+      <p:pic>
+        <p:nvPicPr>
+          <p:cNvPr id="5" name="Picture 4">
+            <a:extLst>
+              <a:ext uri="{FF2B5EF4-FFF2-40B4-BE49-F238E27FC236}">
+                <a16:creationId xmlns:a16="http://schemas.microsoft.com/office/drawing/2014/main" id="{A76C55FF-D198-AE52-ABE8-2CB06EEB97E3}"/>
+              </a:ext>
+            </a:extLst>
+          </p:cNvPr>
+          <p:cNvPicPr>
+            <a:picLocks noChangeAspect="1"/>
+          </p:cNvPicPr>
+          <p:nvPr/>
+        </p:nvPicPr>
+        <p:blipFill>
+          <a:blip r:embed="rId2"/>
+          <a:stretch>
+            <a:fillRect/>
+          </a:stretch>
+        </p:blipFill>
+        <p:spPr>
+          <a:xfrm>
+            <a:off x="952500" y="0"/>
+            <a:ext cx="10287000" cy="6858000"/>
+          </a:xfrm>
+          <a:prstGeom prst="rect">
+            <a:avLst/>
+          </a:prstGeom>
+        </p:spPr>
+      </p:pic>
+      <p:sp>
+        <p:nvSpPr>
+          <p:cNvPr id="6" name="Rectangle 5">
+            <a:extLst>
+              <a:ext uri="{FF2B5EF4-FFF2-40B4-BE49-F238E27FC236}">
+                <a16:creationId xmlns:a16="http://schemas.microsoft.com/office/drawing/2014/main" id="{AB2D4920-9A0D-E96E-C393-31C5CC6A1E54}"/>
+              </a:ext>
+            </a:extLst>
+          </p:cNvPr>
+          <p:cNvSpPr/>
+          <p:nvPr/>
+        </p:nvSpPr>
+        <p:spPr>
+          <a:xfrm>
+            <a:off x="3640328" y="739303"/>
+            <a:ext cx="7390838" cy="2689697"/>
+          </a:xfrm>
+          <a:prstGeom prst="rect">
+            <a:avLst/>
+          </a:prstGeom>
+          <a:noFill/>
+          <a:ln w="28575">
+            <a:solidFill>
+              <a:srgbClr val="C00000"/>
+            </a:solidFill>
+          </a:ln>
+        </p:spPr>
+        <p:style>
+          <a:lnRef idx="2">
+            <a:schemeClr val="accent1">
+              <a:shade val="15000"/>
+            </a:schemeClr>
+          </a:lnRef>
+          <a:fillRef idx="1">
+            <a:schemeClr val="accent1"/>
+          </a:fillRef>
+          <a:effectRef idx="0">
+            <a:schemeClr val="accent1"/>
+          </a:effectRef>
+          <a:fontRef idx="minor">
+            <a:schemeClr val="lt1"/>
+          </a:fontRef>
+        </p:style>
+        <p:txBody>
+          <a:bodyPr rtlCol="0" anchor="ctr"/>
+          <a:lstStyle/>
+          <a:p>
+            <a:pPr algn="ctr"/>
+            <a:endParaRPr lang="en-GB"/>
+          </a:p>
+        </p:txBody>
+      </p:sp>
+      <p:sp>
+        <p:nvSpPr>
+          <p:cNvPr id="7" name="TextBox 6">
+            <a:extLst>
+              <a:ext uri="{FF2B5EF4-FFF2-40B4-BE49-F238E27FC236}">
+                <a16:creationId xmlns:a16="http://schemas.microsoft.com/office/drawing/2014/main" id="{3D3272D1-0FF4-0A94-86FE-5387CF2D3A21}"/>
+              </a:ext>
+            </a:extLst>
+          </p:cNvPr>
+          <p:cNvSpPr txBox="1"/>
+          <p:nvPr/>
+        </p:nvSpPr>
+        <p:spPr>
+          <a:xfrm>
+            <a:off x="5600903" y="2084151"/>
+            <a:ext cx="3689620" cy="369332"/>
+          </a:xfrm>
+          <a:prstGeom prst="rect">
+            <a:avLst/>
+          </a:prstGeom>
+          <a:noFill/>
+        </p:spPr>
+        <p:txBody>
+          <a:bodyPr wrap="square" rtlCol="0">
+            <a:spAutoFit/>
+          </a:bodyPr>
+          <a:lstStyle/>
+          <a:p>
+            <a:r>
+              <a:rPr lang="en-GB" dirty="0">
+                <a:solidFill>
+                  <a:srgbClr val="C00000"/>
+                </a:solidFill>
+              </a:rPr>
+              <a:t>Area to start entering commands</a:t>
+            </a:r>
+          </a:p>
+        </p:txBody>
+      </p:sp>
+      <p:sp>
+        <p:nvSpPr>
+          <p:cNvPr id="8" name="Rectangle 7">
+            <a:extLst>
+              <a:ext uri="{FF2B5EF4-FFF2-40B4-BE49-F238E27FC236}">
+                <a16:creationId xmlns:a16="http://schemas.microsoft.com/office/drawing/2014/main" id="{EF9DF620-C602-9D2F-902D-CD25207C2CAE}"/>
+              </a:ext>
+            </a:extLst>
+          </p:cNvPr>
+          <p:cNvSpPr/>
+          <p:nvPr/>
+        </p:nvSpPr>
+        <p:spPr>
+          <a:xfrm>
+            <a:off x="3394953" y="5943600"/>
+            <a:ext cx="7636213" cy="418289"/>
+          </a:xfrm>
+          <a:prstGeom prst="rect">
+            <a:avLst/>
+          </a:prstGeom>
+          <a:noFill/>
+          <a:ln w="28575">
+            <a:solidFill>
+              <a:srgbClr val="C00000"/>
+            </a:solidFill>
+          </a:ln>
+        </p:spPr>
+        <p:style>
+          <a:lnRef idx="2">
+            <a:schemeClr val="accent1">
+              <a:shade val="15000"/>
+            </a:schemeClr>
+          </a:lnRef>
+          <a:fillRef idx="1">
+            <a:schemeClr val="accent1"/>
+          </a:fillRef>
+          <a:effectRef idx="0">
+            <a:schemeClr val="accent1"/>
+          </a:effectRef>
+          <a:fontRef idx="minor">
+            <a:schemeClr val="lt1"/>
+          </a:fontRef>
+        </p:style>
+        <p:txBody>
+          <a:bodyPr rtlCol="0" anchor="ctr"/>
+          <a:lstStyle/>
+          <a:p>
+            <a:pPr algn="ctr"/>
+            <a:endParaRPr lang="en-GB"/>
+          </a:p>
+        </p:txBody>
+      </p:sp>
+      <p:sp>
+        <p:nvSpPr>
+          <p:cNvPr id="9" name="TextBox 8">
+            <a:extLst>
+              <a:ext uri="{FF2B5EF4-FFF2-40B4-BE49-F238E27FC236}">
+                <a16:creationId xmlns:a16="http://schemas.microsoft.com/office/drawing/2014/main" id="{6BC487D4-140A-77D6-45D5-38B6F31EE99D}"/>
+              </a:ext>
+            </a:extLst>
+          </p:cNvPr>
+          <p:cNvSpPr txBox="1"/>
+          <p:nvPr/>
+        </p:nvSpPr>
+        <p:spPr>
+          <a:xfrm>
+            <a:off x="7549880" y="5574268"/>
+            <a:ext cx="3566043" cy="369332"/>
+          </a:xfrm>
+          <a:prstGeom prst="rect">
+            <a:avLst/>
+          </a:prstGeom>
+          <a:noFill/>
+        </p:spPr>
+        <p:txBody>
+          <a:bodyPr wrap="square" rtlCol="0">
+            <a:spAutoFit/>
+          </a:bodyPr>
+          <a:lstStyle/>
+          <a:p>
+            <a:pPr algn="r"/>
+            <a:r>
+              <a:rPr lang="en-GB" dirty="0">
+                <a:solidFill>
+                  <a:srgbClr val="C00000"/>
+                </a:solidFill>
+              </a:rPr>
+              <a:t>Built in terminal prompt</a:t>
+            </a:r>
+          </a:p>
+        </p:txBody>
+      </p:sp>
+    </p:spTree>
+    <p:extLst>
+      <p:ext uri="{BB962C8B-B14F-4D97-AF65-F5344CB8AC3E}">
+        <p14:creationId xmlns:p14="http://schemas.microsoft.com/office/powerpoint/2010/main" val="2323277968"/>
       </p:ext>
     </p:extLst>
   </p:cSld>

</xml_diff>